<commit_message>
Modified the APIs for CAN-TP, added can_idx as a parameter
</commit_message>
<xml_diff>
--- a/20_Design/CAN_TP/DS_OBD_Stack_CAN_TP.pptx
+++ b/20_Design/CAN_TP/DS_OBD_Stack_CAN_TP.pptx
@@ -263,7 +263,7 @@
           <a:p>
             <a:fld id="{DAD19FF4-7AB3-4761-ACA3-26E62BAEB0BC}" type="datetimeFigureOut">
               <a:rPr lang="en-IN" smtClean="0"/>
-              <a:t>11-04-2025</a:t>
+              <a:t>17-04-2025</a:t>
             </a:fld>
             <a:endParaRPr lang="en-IN"/>
           </a:p>
@@ -463,7 +463,7 @@
           <a:p>
             <a:fld id="{DAD19FF4-7AB3-4761-ACA3-26E62BAEB0BC}" type="datetimeFigureOut">
               <a:rPr lang="en-IN" smtClean="0"/>
-              <a:t>11-04-2025</a:t>
+              <a:t>17-04-2025</a:t>
             </a:fld>
             <a:endParaRPr lang="en-IN"/>
           </a:p>
@@ -673,7 +673,7 @@
           <a:p>
             <a:fld id="{DAD19FF4-7AB3-4761-ACA3-26E62BAEB0BC}" type="datetimeFigureOut">
               <a:rPr lang="en-IN" smtClean="0"/>
-              <a:t>11-04-2025</a:t>
+              <a:t>17-04-2025</a:t>
             </a:fld>
             <a:endParaRPr lang="en-IN"/>
           </a:p>
@@ -873,7 +873,7 @@
           <a:p>
             <a:fld id="{DAD19FF4-7AB3-4761-ACA3-26E62BAEB0BC}" type="datetimeFigureOut">
               <a:rPr lang="en-IN" smtClean="0"/>
-              <a:t>11-04-2025</a:t>
+              <a:t>17-04-2025</a:t>
             </a:fld>
             <a:endParaRPr lang="en-IN"/>
           </a:p>
@@ -1149,7 +1149,7 @@
           <a:p>
             <a:fld id="{DAD19FF4-7AB3-4761-ACA3-26E62BAEB0BC}" type="datetimeFigureOut">
               <a:rPr lang="en-IN" smtClean="0"/>
-              <a:t>11-04-2025</a:t>
+              <a:t>17-04-2025</a:t>
             </a:fld>
             <a:endParaRPr lang="en-IN"/>
           </a:p>
@@ -1417,7 +1417,7 @@
           <a:p>
             <a:fld id="{DAD19FF4-7AB3-4761-ACA3-26E62BAEB0BC}" type="datetimeFigureOut">
               <a:rPr lang="en-IN" smtClean="0"/>
-              <a:t>11-04-2025</a:t>
+              <a:t>17-04-2025</a:t>
             </a:fld>
             <a:endParaRPr lang="en-IN"/>
           </a:p>
@@ -1832,7 +1832,7 @@
           <a:p>
             <a:fld id="{DAD19FF4-7AB3-4761-ACA3-26E62BAEB0BC}" type="datetimeFigureOut">
               <a:rPr lang="en-IN" smtClean="0"/>
-              <a:t>11-04-2025</a:t>
+              <a:t>17-04-2025</a:t>
             </a:fld>
             <a:endParaRPr lang="en-IN"/>
           </a:p>
@@ -1974,7 +1974,7 @@
           <a:p>
             <a:fld id="{DAD19FF4-7AB3-4761-ACA3-26E62BAEB0BC}" type="datetimeFigureOut">
               <a:rPr lang="en-IN" smtClean="0"/>
-              <a:t>11-04-2025</a:t>
+              <a:t>17-04-2025</a:t>
             </a:fld>
             <a:endParaRPr lang="en-IN"/>
           </a:p>
@@ -2087,7 +2087,7 @@
           <a:p>
             <a:fld id="{DAD19FF4-7AB3-4761-ACA3-26E62BAEB0BC}" type="datetimeFigureOut">
               <a:rPr lang="en-IN" smtClean="0"/>
-              <a:t>11-04-2025</a:t>
+              <a:t>17-04-2025</a:t>
             </a:fld>
             <a:endParaRPr lang="en-IN"/>
           </a:p>
@@ -2400,7 +2400,7 @@
           <a:p>
             <a:fld id="{DAD19FF4-7AB3-4761-ACA3-26E62BAEB0BC}" type="datetimeFigureOut">
               <a:rPr lang="en-IN" smtClean="0"/>
-              <a:t>11-04-2025</a:t>
+              <a:t>17-04-2025</a:t>
             </a:fld>
             <a:endParaRPr lang="en-IN"/>
           </a:p>
@@ -2689,7 +2689,7 @@
           <a:p>
             <a:fld id="{DAD19FF4-7AB3-4761-ACA3-26E62BAEB0BC}" type="datetimeFigureOut">
               <a:rPr lang="en-IN" smtClean="0"/>
-              <a:t>11-04-2025</a:t>
+              <a:t>17-04-2025</a:t>
             </a:fld>
             <a:endParaRPr lang="en-IN"/>
           </a:p>
@@ -2932,7 +2932,7 @@
           <a:p>
             <a:fld id="{DAD19FF4-7AB3-4761-ACA3-26E62BAEB0BC}" type="datetimeFigureOut">
               <a:rPr lang="en-IN" smtClean="0"/>
-              <a:t>11-04-2025</a:t>
+              <a:t>17-04-2025</a:t>
             </a:fld>
             <a:endParaRPr lang="en-IN"/>
           </a:p>
@@ -3511,21 +3511,49 @@
               <a:t>(</a:t>
             </a:r>
             <a:r>
-              <a:rPr lang="en-IN" sz="3200" dirty="0" err="1">
-                <a:latin typeface="Times New Roman" panose="02020603050405020304" pitchFamily="18" charset="0"/>
-                <a:cs typeface="Times New Roman" panose="02020603050405020304" pitchFamily="18" charset="0"/>
-              </a:rPr>
-              <a:t>can_frame</a:t>
-            </a:r>
-            <a:r>
-              <a:rPr lang="en-IN" sz="3200" dirty="0">
-                <a:latin typeface="Times New Roman" panose="02020603050405020304" pitchFamily="18" charset="0"/>
-                <a:cs typeface="Times New Roman" panose="02020603050405020304" pitchFamily="18" charset="0"/>
-              </a:rPr>
-              <a:t> *data, uint16 </a:t>
-            </a:r>
-            <a:r>
-              <a:rPr lang="en-IN" sz="3200" dirty="0" err="1">
+              <a:rPr lang="en-US" sz="3200" dirty="0" err="1">
+                <a:latin typeface="Times New Roman" panose="02020603050405020304" pitchFamily="18" charset="0"/>
+                <a:cs typeface="Times New Roman" panose="02020603050405020304" pitchFamily="18" charset="0"/>
+              </a:rPr>
+              <a:t>can_idx_t</a:t>
+            </a:r>
+            <a:r>
+              <a:rPr lang="en-US" sz="3200" dirty="0">
+                <a:latin typeface="Times New Roman" panose="02020603050405020304" pitchFamily="18" charset="0"/>
+                <a:cs typeface="Times New Roman" panose="02020603050405020304" pitchFamily="18" charset="0"/>
+              </a:rPr>
+              <a:t> </a:t>
+            </a:r>
+            <a:r>
+              <a:rPr lang="en-US" sz="3200" dirty="0" err="1">
+                <a:latin typeface="Times New Roman" panose="02020603050405020304" pitchFamily="18" charset="0"/>
+                <a:cs typeface="Times New Roman" panose="02020603050405020304" pitchFamily="18" charset="0"/>
+              </a:rPr>
+              <a:t>CanIdx</a:t>
+            </a:r>
+            <a:r>
+              <a:rPr lang="en-US" sz="3200" dirty="0">
+                <a:latin typeface="Times New Roman" panose="02020603050405020304" pitchFamily="18" charset="0"/>
+                <a:cs typeface="Times New Roman" panose="02020603050405020304" pitchFamily="18" charset="0"/>
+              </a:rPr>
+              <a:t>, </a:t>
+            </a:r>
+            <a:r>
+              <a:rPr lang="en-US" sz="3200" dirty="0" err="1">
+                <a:latin typeface="Times New Roman" panose="02020603050405020304" pitchFamily="18" charset="0"/>
+                <a:cs typeface="Times New Roman" panose="02020603050405020304" pitchFamily="18" charset="0"/>
+              </a:rPr>
+              <a:t>can_msg_t</a:t>
+            </a:r>
+            <a:r>
+              <a:rPr lang="en-US" sz="3200" dirty="0">
+                <a:latin typeface="Times New Roman" panose="02020603050405020304" pitchFamily="18" charset="0"/>
+                <a:cs typeface="Times New Roman" panose="02020603050405020304" pitchFamily="18" charset="0"/>
+              </a:rPr>
+              <a:t> data, uint16 </a:t>
+            </a:r>
+            <a:r>
+              <a:rPr lang="en-US" sz="3200" dirty="0" err="1">
                 <a:latin typeface="Times New Roman" panose="02020603050405020304" pitchFamily="18" charset="0"/>
                 <a:cs typeface="Times New Roman" panose="02020603050405020304" pitchFamily="18" charset="0"/>
               </a:rPr>
@@ -3726,7 +3754,26 @@
                 <a:latin typeface="Times New Roman" panose="02020603050405020304" pitchFamily="18" charset="0"/>
                 <a:cs typeface="Times New Roman" panose="02020603050405020304" pitchFamily="18" charset="0"/>
               </a:rPr>
-              <a:t>can_frame</a:t>
+              <a:t>can_idx_t</a:t>
+            </a:r>
+            <a:r>
+              <a:rPr lang="en-US" dirty="0">
+                <a:latin typeface="Times New Roman" panose="02020603050405020304" pitchFamily="18" charset="0"/>
+                <a:cs typeface="Times New Roman" panose="02020603050405020304" pitchFamily="18" charset="0"/>
+              </a:rPr>
+              <a:t>- Specifies which CAN controller should be used.</a:t>
+            </a:r>
+          </a:p>
+          <a:p>
+            <a:pPr marL="0" indent="0" algn="just">
+              <a:buNone/>
+            </a:pPr>
+            <a:r>
+              <a:rPr lang="en-US" dirty="0" err="1">
+                <a:latin typeface="Times New Roman" panose="02020603050405020304" pitchFamily="18" charset="0"/>
+                <a:cs typeface="Times New Roman" panose="02020603050405020304" pitchFamily="18" charset="0"/>
+              </a:rPr>
+              <a:t>can_msg_t</a:t>
             </a:r>
             <a:r>
               <a:rPr lang="en-US" dirty="0">
@@ -3994,7 +4041,7 @@
         </p:spPr>
         <p:txBody>
           <a:bodyPr vert="horz" lIns="91440" tIns="45720" rIns="91440" bIns="45720" rtlCol="0" anchor="ctr">
-            <a:normAutofit/>
+            <a:normAutofit lnSpcReduction="10000"/>
           </a:bodyPr>
           <a:lstStyle>
             <a:lvl1pPr algn="ctr" defTabSz="457200" rtl="0" eaLnBrk="1" latinLnBrk="0" hangingPunct="1">
@@ -4043,21 +4090,49 @@
               <a:t>(</a:t>
             </a:r>
             <a:r>
-              <a:rPr lang="en-IN" sz="3400" dirty="0" err="1">
-                <a:latin typeface="Times New Roman" panose="02020603050405020304" pitchFamily="18" charset="0"/>
-                <a:cs typeface="Times New Roman" panose="02020603050405020304" pitchFamily="18" charset="0"/>
-              </a:rPr>
-              <a:t>can_frame</a:t>
-            </a:r>
-            <a:r>
-              <a:rPr lang="en-IN" sz="3400" dirty="0">
-                <a:latin typeface="Times New Roman" panose="02020603050405020304" pitchFamily="18" charset="0"/>
-                <a:cs typeface="Times New Roman" panose="02020603050405020304" pitchFamily="18" charset="0"/>
-              </a:rPr>
-              <a:t> *data, uint16 </a:t>
-            </a:r>
-            <a:r>
-              <a:rPr lang="en-IN" sz="3400" dirty="0" err="1">
+              <a:rPr lang="en-US" sz="3400" dirty="0" err="1">
+                <a:latin typeface="Times New Roman" panose="02020603050405020304" pitchFamily="18" charset="0"/>
+                <a:cs typeface="Times New Roman" panose="02020603050405020304" pitchFamily="18" charset="0"/>
+              </a:rPr>
+              <a:t>can_idx_t</a:t>
+            </a:r>
+            <a:r>
+              <a:rPr lang="en-US" sz="3400" dirty="0">
+                <a:latin typeface="Times New Roman" panose="02020603050405020304" pitchFamily="18" charset="0"/>
+                <a:cs typeface="Times New Roman" panose="02020603050405020304" pitchFamily="18" charset="0"/>
+              </a:rPr>
+              <a:t> </a:t>
+            </a:r>
+            <a:r>
+              <a:rPr lang="en-US" sz="3400" dirty="0" err="1">
+                <a:latin typeface="Times New Roman" panose="02020603050405020304" pitchFamily="18" charset="0"/>
+                <a:cs typeface="Times New Roman" panose="02020603050405020304" pitchFamily="18" charset="0"/>
+              </a:rPr>
+              <a:t>CanIdx</a:t>
+            </a:r>
+            <a:r>
+              <a:rPr lang="en-US" sz="3400" dirty="0">
+                <a:latin typeface="Times New Roman" panose="02020603050405020304" pitchFamily="18" charset="0"/>
+                <a:cs typeface="Times New Roman" panose="02020603050405020304" pitchFamily="18" charset="0"/>
+              </a:rPr>
+              <a:t>, </a:t>
+            </a:r>
+            <a:r>
+              <a:rPr lang="en-US" sz="3400" dirty="0" err="1">
+                <a:latin typeface="Times New Roman" panose="02020603050405020304" pitchFamily="18" charset="0"/>
+                <a:cs typeface="Times New Roman" panose="02020603050405020304" pitchFamily="18" charset="0"/>
+              </a:rPr>
+              <a:t>can_msg_t</a:t>
+            </a:r>
+            <a:r>
+              <a:rPr lang="en-US" sz="3400" dirty="0">
+                <a:latin typeface="Times New Roman" panose="02020603050405020304" pitchFamily="18" charset="0"/>
+                <a:cs typeface="Times New Roman" panose="02020603050405020304" pitchFamily="18" charset="0"/>
+              </a:rPr>
+              <a:t> data, uint16 </a:t>
+            </a:r>
+            <a:r>
+              <a:rPr lang="en-US" sz="3400" dirty="0" err="1">
                 <a:latin typeface="Times New Roman" panose="02020603050405020304" pitchFamily="18" charset="0"/>
                 <a:cs typeface="Times New Roman" panose="02020603050405020304" pitchFamily="18" charset="0"/>
               </a:rPr>
@@ -4258,14 +4333,37 @@
                 <a:latin typeface="Times New Roman" panose="02020603050405020304" pitchFamily="18" charset="0"/>
                 <a:cs typeface="Times New Roman" panose="02020603050405020304" pitchFamily="18" charset="0"/>
               </a:rPr>
-              <a:t>can_frame</a:t>
+              <a:t>can_idx_t</a:t>
             </a:r>
             <a:r>
               <a:rPr lang="en-US" dirty="0">
                 <a:latin typeface="Times New Roman" panose="02020603050405020304" pitchFamily="18" charset="0"/>
                 <a:cs typeface="Times New Roman" panose="02020603050405020304" pitchFamily="18" charset="0"/>
               </a:rPr>
-              <a:t>- Structure that includes id, data, length.</a:t>
+              <a:t>- Specifies which CAN controller should be used.</a:t>
+            </a:r>
+            <a:endParaRPr lang="en-US" b="1" dirty="0">
+              <a:latin typeface="Times New Roman" panose="02020603050405020304" pitchFamily="18" charset="0"/>
+              <a:cs typeface="Times New Roman" panose="02020603050405020304" pitchFamily="18" charset="0"/>
+            </a:endParaRPr>
+          </a:p>
+          <a:p>
+            <a:pPr marL="0" indent="0" algn="just">
+              <a:buNone/>
+            </a:pPr>
+            <a:r>
+              <a:rPr lang="en-US" dirty="0" err="1">
+                <a:latin typeface="Times New Roman" panose="02020603050405020304" pitchFamily="18" charset="0"/>
+                <a:cs typeface="Times New Roman" panose="02020603050405020304" pitchFamily="18" charset="0"/>
+              </a:rPr>
+              <a:t>can_msg_t</a:t>
+            </a:r>
+            <a:r>
+              <a:rPr lang="en-US" dirty="0">
+                <a:latin typeface="Times New Roman" panose="02020603050405020304" pitchFamily="18" charset="0"/>
+                <a:cs typeface="Times New Roman" panose="02020603050405020304" pitchFamily="18" charset="0"/>
+              </a:rPr>
+              <a:t> -  Structure that includes id, data, length.</a:t>
             </a:r>
           </a:p>
           <a:p>

</xml_diff>

<commit_message>
Updated the parameters of the design
</commit_message>
<xml_diff>
--- a/20_Design/CAN_TP/DS_OBD_Stack_CAN_TP.pptx
+++ b/20_Design/CAN_TP/DS_OBD_Stack_CAN_TP.pptx
@@ -3529,7 +3529,7 @@
                 <a:latin typeface="Times New Roman" panose="02020603050405020304" pitchFamily="18" charset="0"/>
                 <a:cs typeface="Times New Roman" panose="02020603050405020304" pitchFamily="18" charset="0"/>
               </a:rPr>
-              <a:t>CanIdx</a:t>
+              <a:t>can_idx</a:t>
             </a:r>
             <a:r>
               <a:rPr lang="en-US" sz="3200" dirty="0">
@@ -4104,11 +4104,11 @@
               <a:t> </a:t>
             </a:r>
             <a:r>
-              <a:rPr lang="en-US" sz="3400" dirty="0" err="1">
-                <a:latin typeface="Times New Roman" panose="02020603050405020304" pitchFamily="18" charset="0"/>
-                <a:cs typeface="Times New Roman" panose="02020603050405020304" pitchFamily="18" charset="0"/>
-              </a:rPr>
-              <a:t>CanIdx</a:t>
+              <a:rPr lang="en-US" sz="3400">
+                <a:latin typeface="Times New Roman" panose="02020603050405020304" pitchFamily="18" charset="0"/>
+                <a:cs typeface="Times New Roman" panose="02020603050405020304" pitchFamily="18" charset="0"/>
+              </a:rPr>
+              <a:t>can_idx</a:t>
             </a:r>
             <a:r>
               <a:rPr lang="en-US" sz="3400" dirty="0">

</xml_diff>

<commit_message>
Updated the receive API by passing the pointer of data
</commit_message>
<xml_diff>
--- a/20_Design/CAN_TP/DS_OBD_Stack_CAN_TP.pptx
+++ b/20_Design/CAN_TP/DS_OBD_Stack_CAN_TP.pptx
@@ -4104,7 +4104,7 @@
               <a:t> </a:t>
             </a:r>
             <a:r>
-              <a:rPr lang="en-US" sz="3400">
+              <a:rPr lang="en-US" sz="3400" dirty="0" err="1">
                 <a:latin typeface="Times New Roman" panose="02020603050405020304" pitchFamily="18" charset="0"/>
                 <a:cs typeface="Times New Roman" panose="02020603050405020304" pitchFamily="18" charset="0"/>
               </a:rPr>
@@ -4129,7 +4129,7 @@
                 <a:latin typeface="Times New Roman" panose="02020603050405020304" pitchFamily="18" charset="0"/>
                 <a:cs typeface="Times New Roman" panose="02020603050405020304" pitchFamily="18" charset="0"/>
               </a:rPr>
-              <a:t> data, uint16 </a:t>
+              <a:t> *data, uint16 </a:t>
             </a:r>
             <a:r>
               <a:rPr lang="en-US" sz="3400" dirty="0" err="1">

</xml_diff>